<commit_message>
Pitch fix: Pepper's Ghost is a 45-degree acrylic sheet, not a pyramid
Redraw the title motif and the slide-2 diagram as a tilted sheet with the light path and the floating virtual image; update the speech script, Chinese reference and pronunciation table to match.

Co-Authored-By: Claude Fable 5 <noreply@anthropic.com>
</commit_message>
<xml_diff>
--- a/Exhibition_Pitch_1min.pptx
+++ b/Exhibition_Pitch_1min.pptx
@@ -595,7 +595,7 @@
           <a:p>
             <a:r>
               <a:rPr lang="en-US" dirty="0"/>
-              <a:t>An iPad lies flat on the desk. An acrylic pyramid stands on top. The screen reflects into the pyramid - so a 3D librarian floats in the air.</a:t>
+              <a:t>An iPad lies flat on the desk. A clear acrylic sheet stands over it, at 45 degrees. The screen reflects on the sheet - so a 3D librarian floats in the air. This old trick is called Pepper's Ghost.</a:t>
             </a:r>
             <a:endParaRPr lang="en-US" dirty="0"/>
           </a:p>
@@ -1328,31 +1328,6 @@
         </p:nvSpPr>
         <p:spPr>
           <a:xfrm>
-            <a:off x="7452360" y="1417320"/>
-            <a:ext cx="3840480" cy="3291840"/>
-          </a:xfrm>
-          <a:prstGeom prst="triangle">
-            <a:avLst/>
-          </a:prstGeom>
-          <a:solidFill>
-            <a:srgbClr val="13201B"/>
-          </a:solidFill>
-          <a:ln w="19050">
-            <a:solidFill>
-              <a:srgbClr val="7BE0C9"/>
-            </a:solidFill>
-            <a:prstDash val="solid"/>
-          </a:ln>
-        </p:spPr>
-      </p:sp>
-      <p:sp>
-        <p:nvSpPr>
-          <p:cNvPr id="3" name="Shape 1"/>
-          <p:cNvSpPr/>
-          <p:nvPr/>
-        </p:nvSpPr>
-        <p:spPr>
-          <a:xfrm>
             <a:off x="7635240" y="4800600"/>
             <a:ext cx="3474720" cy="256032"/>
           </a:xfrm>
@@ -1374,14 +1349,41 @@
       </p:sp>
       <p:sp>
         <p:nvSpPr>
+          <p:cNvPr id="3" name="Shape 1"/>
+          <p:cNvSpPr/>
+          <p:nvPr/>
+        </p:nvSpPr>
+        <p:spPr>
+          <a:xfrm rot="18900000">
+            <a:off x="8092440" y="3246120"/>
+            <a:ext cx="2651760" cy="91440"/>
+          </a:xfrm>
+          <a:prstGeom prst="rect">
+            <a:avLst/>
+          </a:prstGeom>
+          <a:solidFill>
+            <a:srgbClr val="7BE0C9">
+              <a:alpha val="28000"/>
+            </a:srgbClr>
+          </a:solidFill>
+          <a:ln w="15875">
+            <a:solidFill>
+              <a:srgbClr val="7BE0C9"/>
+            </a:solidFill>
+            <a:prstDash val="solid"/>
+          </a:ln>
+        </p:spPr>
+      </p:sp>
+      <p:sp>
+        <p:nvSpPr>
           <p:cNvPr id="4" name="Shape 2"/>
           <p:cNvSpPr/>
           <p:nvPr/>
         </p:nvSpPr>
         <p:spPr>
           <a:xfrm>
-            <a:off x="9052560" y="2468880"/>
-            <a:ext cx="640080" cy="640080"/>
+            <a:off x="9921240" y="2148840"/>
+            <a:ext cx="566928" cy="566928"/>
           </a:xfrm>
           <a:prstGeom prst="ellipse">
             <a:avLst/>
@@ -1402,8 +1404,8 @@
         </p:nvSpPr>
         <p:spPr>
           <a:xfrm>
-            <a:off x="8869680" y="3154680"/>
-            <a:ext cx="1005840" cy="1234440"/>
+            <a:off x="9756648" y="2761488"/>
+            <a:ext cx="914400" cy="1143000"/>
           </a:xfrm>
           <a:prstGeom prst="ellipse">
             <a:avLst/>
@@ -1895,7 +1897,7 @@
                 <a:ea typeface="Arial" pitchFamily="34" charset="-122"/>
                 <a:cs typeface="Arial" pitchFamily="34" charset="-120"/>
               </a:rPr>
-              <a:t>An acrylic pyramid stands on top</a:t>
+              <a:t>A clear acrylic sheet stands over it, at 45°</a:t>
             </a:r>
             <a:endParaRPr lang="en-US" sz="1600" dirty="0"/>
           </a:p>
@@ -2035,14 +2037,82 @@
         </p:nvSpPr>
         <p:spPr>
           <a:xfrm>
-            <a:off x="7635240" y="1965960"/>
-            <a:ext cx="3108960" cy="2651760"/>
-          </a:xfrm>
-          <a:prstGeom prst="triangle">
-            <a:avLst/>
-          </a:prstGeom>
-          <a:solidFill>
-            <a:srgbClr val="13201B"/>
+            <a:off x="7360920" y="4709160"/>
+            <a:ext cx="3657600" cy="292608"/>
+          </a:xfrm>
+          <a:prstGeom prst="roundRect">
+            <a:avLst>
+              <a:gd name="adj" fmla="val 37500"/>
+            </a:avLst>
+          </a:prstGeom>
+          <a:solidFill>
+            <a:srgbClr val="182A23"/>
+          </a:solidFill>
+          <a:ln w="12700">
+            <a:solidFill>
+              <a:srgbClr val="93A8A1"/>
+            </a:solidFill>
+            <a:prstDash val="solid"/>
+          </a:ln>
+        </p:spPr>
+      </p:sp>
+      <p:sp>
+        <p:nvSpPr>
+          <p:cNvPr id="13" name="Text 11"/>
+          <p:cNvSpPr/>
+          <p:nvPr/>
+        </p:nvSpPr>
+        <p:spPr>
+          <a:xfrm>
+            <a:off x="7360920" y="5074920"/>
+            <a:ext cx="3657600" cy="320040"/>
+          </a:xfrm>
+          <a:prstGeom prst="rect">
+            <a:avLst/>
+          </a:prstGeom>
+          <a:noFill/>
+          <a:ln/>
+        </p:spPr>
+        <p:txBody>
+          <a:bodyPr wrap="square" lIns="0" tIns="0" rIns="0" bIns="0" rtlCol="0" anchor="ctr"/>
+          <a:lstStyle/>
+          <a:p>
+            <a:pPr algn="ctr" indent="0" marL="0">
+              <a:buNone/>
+            </a:pPr>
+            <a:r>
+              <a:rPr lang="en-US" sz="1100" dirty="0">
+                <a:solidFill>
+                  <a:srgbClr val="93A8A1"/>
+                </a:solidFill>
+                <a:latin typeface="Arial" pitchFamily="34" charset="0"/>
+                <a:ea typeface="Arial" pitchFamily="34" charset="-122"/>
+                <a:cs typeface="Arial" pitchFamily="34" charset="-120"/>
+              </a:rPr>
+              <a:t>iPad (screen up)</a:t>
+            </a:r>
+            <a:endParaRPr lang="en-US" sz="1100" dirty="0"/>
+          </a:p>
+        </p:txBody>
+      </p:sp>
+      <p:sp>
+        <p:nvSpPr>
+          <p:cNvPr id="14" name="Shape 12"/>
+          <p:cNvSpPr/>
+          <p:nvPr/>
+        </p:nvSpPr>
+        <p:spPr>
+          <a:xfrm rot="18900000">
+            <a:off x="7818120" y="3520440"/>
+            <a:ext cx="2377440" cy="82296"/>
+          </a:xfrm>
+          <a:prstGeom prst="rect">
+            <a:avLst/>
+          </a:prstGeom>
+          <a:solidFill>
+            <a:srgbClr val="7BE0C9">
+              <a:alpha val="28000"/>
+            </a:srgbClr>
           </a:solidFill>
           <a:ln w="19050">
             <a:solidFill>
@@ -2054,85 +2124,143 @@
       </p:sp>
       <p:sp>
         <p:nvSpPr>
-          <p:cNvPr id="13" name="Shape 11"/>
-          <p:cNvSpPr/>
-          <p:nvPr/>
-        </p:nvSpPr>
-        <p:spPr>
-          <a:xfrm>
-            <a:off x="8979408" y="2743200"/>
-            <a:ext cx="457200" cy="457200"/>
-          </a:xfrm>
-          <a:prstGeom prst="ellipse">
-            <a:avLst/>
-          </a:prstGeom>
-          <a:solidFill>
-            <a:srgbClr val="7BE0C9">
-              <a:alpha val="85000"/>
-            </a:srgbClr>
-          </a:solidFill>
-          <a:ln/>
-        </p:spPr>
-      </p:sp>
-      <p:sp>
-        <p:nvSpPr>
-          <p:cNvPr id="14" name="Shape 12"/>
-          <p:cNvSpPr/>
-          <p:nvPr/>
-        </p:nvSpPr>
-        <p:spPr>
-          <a:xfrm>
-            <a:off x="8842248" y="3246120"/>
-            <a:ext cx="731520" cy="960120"/>
-          </a:xfrm>
-          <a:prstGeom prst="ellipse">
-            <a:avLst/>
-          </a:prstGeom>
-          <a:solidFill>
-            <a:srgbClr val="7BE0C9">
-              <a:alpha val="50000"/>
-            </a:srgbClr>
-          </a:solidFill>
-          <a:ln/>
-        </p:spPr>
-      </p:sp>
-      <p:sp>
-        <p:nvSpPr>
-          <p:cNvPr id="15" name="Shape 13"/>
-          <p:cNvSpPr/>
-          <p:nvPr/>
-        </p:nvSpPr>
-        <p:spPr>
-          <a:xfrm>
-            <a:off x="7360920" y="4709160"/>
-            <a:ext cx="3657600" cy="292608"/>
-          </a:xfrm>
-          <a:prstGeom prst="roundRect">
-            <a:avLst>
-              <a:gd name="adj" fmla="val 37500"/>
-            </a:avLst>
-          </a:prstGeom>
-          <a:solidFill>
-            <a:srgbClr val="182A23"/>
-          </a:solidFill>
+          <p:cNvPr id="15" name="Text 13"/>
+          <p:cNvSpPr/>
+          <p:nvPr/>
+        </p:nvSpPr>
+        <p:spPr>
+          <a:xfrm>
+            <a:off x="9601200" y="2331720"/>
+            <a:ext cx="1920240" cy="548640"/>
+          </a:xfrm>
+          <a:prstGeom prst="rect">
+            <a:avLst/>
+          </a:prstGeom>
+          <a:noFill/>
+          <a:ln/>
+        </p:spPr>
+        <p:txBody>
+          <a:bodyPr wrap="square" lIns="0" tIns="0" rIns="0" bIns="0" rtlCol="0" anchor="ctr"/>
+          <a:lstStyle/>
+          <a:p>
+            <a:pPr indent="0" marL="0">
+              <a:buNone/>
+            </a:pPr>
+            <a:r>
+              <a:rPr lang="en-US" sz="1100" dirty="0">
+                <a:solidFill>
+                  <a:srgbClr val="93A8A1"/>
+                </a:solidFill>
+                <a:latin typeface="Arial" pitchFamily="34" charset="0"/>
+                <a:ea typeface="Arial" pitchFamily="34" charset="-122"/>
+                <a:cs typeface="Arial" pitchFamily="34" charset="-120"/>
+              </a:rPr>
+              <a:t>clear acrylic sheet · 45°</a:t>
+            </a:r>
+            <a:endParaRPr lang="en-US" sz="1100" dirty="0"/>
+          </a:p>
+        </p:txBody>
+      </p:sp>
+      <p:sp>
+        <p:nvSpPr>
+          <p:cNvPr id="16" name="Shape 14"/>
+          <p:cNvSpPr/>
+          <p:nvPr/>
+        </p:nvSpPr>
+        <p:spPr>
+          <a:xfrm>
+            <a:off x="9006840" y="3657600"/>
+            <a:ext cx="0" cy="1051560"/>
+          </a:xfrm>
+          <a:prstGeom prst="line">
+            <a:avLst/>
+          </a:prstGeom>
+          <a:noFill/>
           <a:ln w="12700">
             <a:solidFill>
               <a:srgbClr val="93A8A1"/>
             </a:solidFill>
-            <a:prstDash val="solid"/>
+            <a:prstDash val="dash"/>
           </a:ln>
         </p:spPr>
       </p:sp>
       <p:sp>
         <p:nvSpPr>
-          <p:cNvPr id="16" name="Text 14"/>
-          <p:cNvSpPr/>
-          <p:nvPr/>
-        </p:nvSpPr>
-        <p:spPr>
-          <a:xfrm>
-            <a:off x="7360920" y="5074920"/>
-            <a:ext cx="3657600" cy="320040"/>
+          <p:cNvPr id="17" name="Shape 15"/>
+          <p:cNvSpPr/>
+          <p:nvPr/>
+        </p:nvSpPr>
+        <p:spPr>
+          <a:xfrm flipV="1">
+            <a:off x="7726680" y="3246120"/>
+            <a:ext cx="1234440" cy="411480"/>
+          </a:xfrm>
+          <a:prstGeom prst="line">
+            <a:avLst/>
+          </a:prstGeom>
+          <a:noFill/>
+          <a:ln w="12700">
+            <a:solidFill>
+              <a:srgbClr val="93A8A1"/>
+            </a:solidFill>
+            <a:prstDash val="dash"/>
+          </a:ln>
+        </p:spPr>
+      </p:sp>
+      <p:sp>
+        <p:nvSpPr>
+          <p:cNvPr id="18" name="Shape 16"/>
+          <p:cNvSpPr/>
+          <p:nvPr/>
+        </p:nvSpPr>
+        <p:spPr>
+          <a:xfrm>
+            <a:off x="7205472" y="2331720"/>
+            <a:ext cx="502920" cy="502920"/>
+          </a:xfrm>
+          <a:prstGeom prst="ellipse">
+            <a:avLst/>
+          </a:prstGeom>
+          <a:solidFill>
+            <a:srgbClr val="7BE0C9">
+              <a:alpha val="80000"/>
+            </a:srgbClr>
+          </a:solidFill>
+          <a:ln/>
+        </p:spPr>
+      </p:sp>
+      <p:sp>
+        <p:nvSpPr>
+          <p:cNvPr id="19" name="Shape 17"/>
+          <p:cNvSpPr/>
+          <p:nvPr/>
+        </p:nvSpPr>
+        <p:spPr>
+          <a:xfrm>
+            <a:off x="7059168" y="2880360"/>
+            <a:ext cx="822960" cy="1051560"/>
+          </a:xfrm>
+          <a:prstGeom prst="ellipse">
+            <a:avLst/>
+          </a:prstGeom>
+          <a:solidFill>
+            <a:srgbClr val="7BE0C9">
+              <a:alpha val="45000"/>
+            </a:srgbClr>
+          </a:solidFill>
+          <a:ln/>
+        </p:spPr>
+      </p:sp>
+      <p:sp>
+        <p:nvSpPr>
+          <p:cNvPr id="20" name="Text 18"/>
+          <p:cNvSpPr/>
+          <p:nvPr/>
+        </p:nvSpPr>
+        <p:spPr>
+          <a:xfrm>
+            <a:off x="6812280" y="4069080"/>
+            <a:ext cx="1417320" cy="640080"/>
           </a:xfrm>
           <a:prstGeom prst="rect">
             <a:avLst/>
@@ -2148,98 +2276,20 @@
               <a:buNone/>
             </a:pPr>
             <a:r>
-              <a:rPr lang="en-US" sz="1100" dirty="0">
-                <a:solidFill>
-                  <a:srgbClr val="93A8A1"/>
-                </a:solidFill>
-                <a:latin typeface="Arial" pitchFamily="34" charset="0"/>
-                <a:ea typeface="Arial" pitchFamily="34" charset="-122"/>
-                <a:cs typeface="Arial" pitchFamily="34" charset="-120"/>
-              </a:rPr>
-              <a:t>iPad (screen up)</a:t>
+              <a:rPr lang="en-US" sz="1100" i="1" dirty="0">
+                <a:solidFill>
+                  <a:srgbClr val="7BE0C9"/>
+                </a:solidFill>
+                <a:latin typeface="Arial" pitchFamily="34" charset="0"/>
+                <a:ea typeface="Arial" pitchFamily="34" charset="-122"/>
+                <a:cs typeface="Arial" pitchFamily="34" charset="-120"/>
+              </a:rPr>
+              <a:t>the librarian</a:t>
             </a:r>
             <a:endParaRPr lang="en-US" sz="1100" dirty="0"/>
           </a:p>
-        </p:txBody>
-      </p:sp>
-      <p:sp>
-        <p:nvSpPr>
-          <p:cNvPr id="17" name="Text 15"/>
-          <p:cNvSpPr/>
-          <p:nvPr/>
-        </p:nvSpPr>
-        <p:spPr>
-          <a:xfrm>
-            <a:off x="10241280" y="1828800"/>
-            <a:ext cx="1463040" cy="548640"/>
-          </a:xfrm>
-          <a:prstGeom prst="rect">
-            <a:avLst/>
-          </a:prstGeom>
-          <a:noFill/>
-          <a:ln/>
-        </p:spPr>
-        <p:txBody>
-          <a:bodyPr wrap="square" lIns="0" tIns="0" rIns="0" bIns="0" rtlCol="0" anchor="ctr"/>
-          <a:lstStyle/>
-          <a:p>
-            <a:pPr indent="0" marL="0">
-              <a:buNone/>
-            </a:pPr>
-            <a:r>
-              <a:rPr lang="en-US" sz="1100" dirty="0">
-                <a:solidFill>
-                  <a:srgbClr val="93A8A1"/>
-                </a:solidFill>
-                <a:latin typeface="Arial" pitchFamily="34" charset="0"/>
-                <a:ea typeface="Arial" pitchFamily="34" charset="-122"/>
-                <a:cs typeface="Arial" pitchFamily="34" charset="-120"/>
-              </a:rPr>
-              <a:t>acrylic pyramid</a:t>
-            </a:r>
-            <a:endParaRPr lang="en-US" sz="1100" dirty="0"/>
-          </a:p>
-        </p:txBody>
-      </p:sp>
-      <p:sp>
-        <p:nvSpPr>
-          <p:cNvPr id="18" name="Text 16"/>
-          <p:cNvSpPr/>
-          <p:nvPr/>
-        </p:nvSpPr>
-        <p:spPr>
-          <a:xfrm>
-            <a:off x="6172200" y="3063240"/>
-            <a:ext cx="1417320" cy="640080"/>
-          </a:xfrm>
-          <a:prstGeom prst="rect">
-            <a:avLst/>
-          </a:prstGeom>
-          <a:noFill/>
-          <a:ln/>
-        </p:spPr>
-        <p:txBody>
-          <a:bodyPr wrap="square" lIns="0" tIns="0" rIns="0" bIns="0" rtlCol="0" anchor="ctr"/>
-          <a:lstStyle/>
-          <a:p>
-            <a:pPr algn="r" indent="0" marL="0">
-              <a:buNone/>
-            </a:pPr>
-            <a:r>
-              <a:rPr lang="en-US" sz="1100" i="1" dirty="0">
-                <a:solidFill>
-                  <a:srgbClr val="7BE0C9"/>
-                </a:solidFill>
-                <a:latin typeface="Arial" pitchFamily="34" charset="0"/>
-                <a:ea typeface="Arial" pitchFamily="34" charset="-122"/>
-                <a:cs typeface="Arial" pitchFamily="34" charset="-120"/>
-              </a:rPr>
-              <a:t>the librarian</a:t>
-            </a:r>
-            <a:endParaRPr lang="en-US" sz="1100" dirty="0"/>
-          </a:p>
-          <a:p>
-            <a:pPr algn="r" indent="0" marL="0">
+          <a:p>
+            <a:pPr algn="ctr" indent="0" marL="0">
               <a:buNone/>
             </a:pPr>
             <a:r>

</xml_diff>

<commit_message>
Pitch: add 'Inside the sensor box' slide (custom PCB, three sensors, data path)
New slide 6 shows the custom PCB shield on the MKR WiFi 1010, the three sensors (VL53L0X distance, BME280 temp/humidity, PN532 NFC), and how data travels: the box broadcasts its own Wi-Fi hotspot and the iPad polls JSON once per second - no internet, no cloud. Speech extended to ~70 s with a matching paragraph.

Co-Authored-By: Claude Fable 5 <noreply@anthropic.com>
</commit_message>
<xml_diff>
--- a/Exhibition_Pitch_1min.pptx
+++ b/Exhibition_Pitch_1min.pptx
@@ -11,9 +11,10 @@
     <p:sldId id="259" r:id="rId5"/>
     <p:sldId id="260" r:id="rId6"/>
     <p:sldId id="261" r:id="rId7"/>
+    <p:sldId id="262" r:id="rId8"/>
   </p:sldIdLst>
   <p:notesMasterIdLst>
-    <p:notesMasterId r:id="rId8"/>
+    <p:notesMasterId r:id="rId9"/>
   </p:notesMasterIdLst>
   <p:sldSz cx="12192000" cy="6858000"/>
   <p:notesSz cx="6858000" cy="12192000"/>
@@ -947,7 +948,7 @@
           <a:p>
             <a:r>
               <a:rPr lang="en-US" dirty="0"/>
-              <a:t>The hardware, the firmware, and the app - all self-made. It runs alone for a whole week. Thank you!</a:t>
+              <a:t>Inside the box: a custom PCB connects three sensors to an Arduino. The box makes its own Wi-Fi. The iPad asks it for data every second. No internet, no cloud - everything stays on the desk.  (point at the sensor box)</a:t>
             </a:r>
             <a:endParaRPr lang="en-US" dirty="0"/>
           </a:p>
@@ -971,6 +972,94 @@
             <a:fld id="{F7021451-1387-4CA6-816F-3879F97B5CBC}" type="slidenum">
               <a:rPr lang="en-US"/>
               <a:t>6</a:t>
+            </a:fld>
+            <a:endParaRPr lang="en-US"/>
+          </a:p>
+        </p:txBody>
+      </p:sp>
+    </p:spTree>
+    <p:extLst>
+      <p:ext uri="{BB962C8B-B14F-4D97-AF65-F5344CB8AC3E}">
+        <p14:creationId xmlns:p14="http://schemas.microsoft.com/office/powerpoint/2010/main" val="1024086991"/>
+      </p:ext>
+    </p:extLst>
+  </p:cSld>
+  <p:clrMapOvr>
+    <a:masterClrMapping/>
+  </p:clrMapOvr>
+</p:notes>
+</file>
+
+<file path=ppt/notesSlides/notesSlide7.xml><?xml version="1.0" encoding="utf-8"?>
+<p:notes xmlns:a="http://schemas.openxmlformats.org/drawingml/2006/main" xmlns:r="http://schemas.openxmlformats.org/officeDocument/2006/relationships" xmlns:p="http://schemas.openxmlformats.org/presentationml/2006/main">
+  <p:cSld>
+    <p:spTree>
+      <p:nvGrpSpPr>
+        <p:cNvPr id="1" name=""/>
+        <p:cNvGrpSpPr/>
+        <p:nvPr/>
+      </p:nvGrpSpPr>
+      <p:grpSpPr>
+        <a:xfrm>
+          <a:off x="0" y="0"/>
+          <a:ext cx="0" cy="0"/>
+          <a:chOff x="0" y="0"/>
+          <a:chExt cx="0" cy="0"/>
+        </a:xfrm>
+      </p:grpSpPr>
+      <p:sp>
+        <p:nvSpPr>
+          <p:cNvPr id="2" name="Slide Image Placeholder 1"/>
+          <p:cNvSpPr>
+            <a:spLocks noGrp="1" noRot="1" noChangeAspect="1"/>
+          </p:cNvSpPr>
+          <p:nvPr>
+            <p:ph type="sldImg"/>
+          </p:nvPr>
+        </p:nvSpPr>
+        <p:spPr/>
+      </p:sp>
+      <p:sp>
+        <p:nvSpPr>
+          <p:cNvPr id="3" name="Notes Placeholder 2"/>
+          <p:cNvSpPr>
+            <a:spLocks noGrp="1"/>
+          </p:cNvSpPr>
+          <p:nvPr>
+            <p:ph type="body" idx="1"/>
+          </p:nvPr>
+        </p:nvSpPr>
+        <p:spPr/>
+        <p:txBody>
+          <a:bodyPr/>
+          <a:lstStyle/>
+          <a:p>
+            <a:r>
+              <a:rPr lang="en-US" dirty="0"/>
+              <a:t>The hardware, the firmware, and the app - all self-made. It runs alone for a whole week. Thank you!</a:t>
+            </a:r>
+            <a:endParaRPr lang="en-US" dirty="0"/>
+          </a:p>
+        </p:txBody>
+      </p:sp>
+      <p:sp>
+        <p:nvSpPr>
+          <p:cNvPr id="4" name="Slide Number Placeholder 3"/>
+          <p:cNvSpPr>
+            <a:spLocks noGrp="1"/>
+          </p:cNvSpPr>
+          <p:nvPr>
+            <p:ph type="sldNum" sz="quarter" idx="10"/>
+          </p:nvPr>
+        </p:nvSpPr>
+        <p:spPr/>
+        <p:txBody>
+          <a:bodyPr/>
+          <a:lstStyle/>
+          <a:p>
+            <a:fld id="{F7021451-1387-4CA6-816F-3879F97B5CBC}" type="slidenum">
+              <a:rPr lang="en-US"/>
+              <a:t>7</a:t>
             </a:fld>
             <a:endParaRPr lang="en-US"/>
           </a:p>
@@ -4241,6 +4330,956 @@
         <p:spPr>
           <a:xfrm>
             <a:off x="1600200" y="566928"/>
+            <a:ext cx="9144000" cy="777240"/>
+          </a:xfrm>
+          <a:prstGeom prst="rect">
+            <a:avLst/>
+          </a:prstGeom>
+          <a:noFill/>
+          <a:ln/>
+        </p:spPr>
+        <p:txBody>
+          <a:bodyPr wrap="square" lIns="0" tIns="0" rIns="0" bIns="0" rtlCol="0" anchor="ctr"/>
+          <a:lstStyle/>
+          <a:p>
+            <a:pPr indent="0" marL="0">
+              <a:buNone/>
+            </a:pPr>
+            <a:r>
+              <a:rPr lang="en-US" sz="3800" b="1" dirty="0">
+                <a:solidFill>
+                  <a:srgbClr val="FFFFFF"/>
+                </a:solidFill>
+                <a:latin typeface="Arial" pitchFamily="34" charset="0"/>
+                <a:ea typeface="Arial" pitchFamily="34" charset="-122"/>
+                <a:cs typeface="Arial" pitchFamily="34" charset="-120"/>
+              </a:rPr>
+              <a:t>Inside the sensor box</a:t>
+            </a:r>
+            <a:endParaRPr lang="en-US" sz="3800" dirty="0"/>
+          </a:p>
+        </p:txBody>
+      </p:sp>
+      <p:sp>
+        <p:nvSpPr>
+          <p:cNvPr id="5" name="Shape 2"/>
+          <p:cNvSpPr/>
+          <p:nvPr/>
+        </p:nvSpPr>
+        <p:spPr>
+          <a:xfrm>
+            <a:off x="685800" y="1783080"/>
+            <a:ext cx="5029200" cy="4206240"/>
+          </a:xfrm>
+          <a:prstGeom prst="roundRect">
+            <a:avLst>
+              <a:gd name="adj" fmla="val 3913"/>
+            </a:avLst>
+          </a:prstGeom>
+          <a:solidFill>
+            <a:srgbClr val="13201B"/>
+          </a:solidFill>
+          <a:ln w="15875">
+            <a:solidFill>
+              <a:srgbClr val="F5B169"/>
+            </a:solidFill>
+            <a:prstDash val="solid"/>
+          </a:ln>
+        </p:spPr>
+      </p:sp>
+      <p:sp>
+        <p:nvSpPr>
+          <p:cNvPr id="6" name="Text 3"/>
+          <p:cNvSpPr/>
+          <p:nvPr/>
+        </p:nvSpPr>
+        <p:spPr>
+          <a:xfrm>
+            <a:off x="960120" y="2011680"/>
+            <a:ext cx="4480560" cy="457200"/>
+          </a:xfrm>
+          <a:prstGeom prst="rect">
+            <a:avLst/>
+          </a:prstGeom>
+          <a:noFill/>
+          <a:ln/>
+        </p:spPr>
+        <p:txBody>
+          <a:bodyPr wrap="square" lIns="0" tIns="0" rIns="0" bIns="0" rtlCol="0" anchor="ctr"/>
+          <a:lstStyle/>
+          <a:p>
+            <a:pPr indent="0" marL="0">
+              <a:buNone/>
+            </a:pPr>
+            <a:r>
+              <a:rPr lang="en-US" sz="2000" b="1" dirty="0">
+                <a:solidFill>
+                  <a:srgbClr val="F5B169"/>
+                </a:solidFill>
+                <a:latin typeface="Arial" pitchFamily="34" charset="0"/>
+                <a:ea typeface="Arial" pitchFamily="34" charset="-122"/>
+                <a:cs typeface="Arial" pitchFamily="34" charset="-120"/>
+              </a:rPr>
+              <a:t>Custom PCB shield</a:t>
+            </a:r>
+            <a:endParaRPr lang="en-US" sz="2000" dirty="0"/>
+          </a:p>
+        </p:txBody>
+      </p:sp>
+      <p:sp>
+        <p:nvSpPr>
+          <p:cNvPr id="7" name="Text 4"/>
+          <p:cNvSpPr/>
+          <p:nvPr/>
+        </p:nvSpPr>
+        <p:spPr>
+          <a:xfrm>
+            <a:off x="960120" y="2487168"/>
+            <a:ext cx="4480560" cy="685800"/>
+          </a:xfrm>
+          <a:prstGeom prst="rect">
+            <a:avLst/>
+          </a:prstGeom>
+          <a:noFill/>
+          <a:ln/>
+        </p:spPr>
+        <p:txBody>
+          <a:bodyPr wrap="square" lIns="0" tIns="0" rIns="0" bIns="0" rtlCol="0" anchor="ctr"/>
+          <a:lstStyle/>
+          <a:p>
+            <a:pPr indent="0" marL="0">
+              <a:lnSpc>
+                <a:spcPts val="1600"/>
+              </a:lnSpc>
+              <a:buNone/>
+            </a:pPr>
+            <a:r>
+              <a:rPr lang="en-US" sz="1200" dirty="0">
+                <a:solidFill>
+                  <a:srgbClr val="93A8A1"/>
+                </a:solidFill>
+                <a:latin typeface="Arial" pitchFamily="34" charset="0"/>
+                <a:ea typeface="Arial" pitchFamily="34" charset="-122"/>
+                <a:cs typeface="Arial" pitchFamily="34" charset="-120"/>
+              </a:rPr>
+              <a:t>self-designed board on an Arduino MKR WiFi 1010 —</a:t>
+            </a:r>
+            <a:endParaRPr lang="en-US" sz="1200" dirty="0"/>
+          </a:p>
+          <a:p>
+            <a:pPr indent="0" marL="0">
+              <a:lnSpc>
+                <a:spcPts val="1600"/>
+              </a:lnSpc>
+              <a:buNone/>
+            </a:pPr>
+            <a:r>
+              <a:rPr lang="en-US" sz="1200" dirty="0">
+                <a:solidFill>
+                  <a:srgbClr val="93A8A1"/>
+                </a:solidFill>
+                <a:latin typeface="Arial" pitchFamily="34" charset="0"/>
+                <a:ea typeface="Arial" pitchFamily="34" charset="-122"/>
+                <a:cs typeface="Arial" pitchFamily="34" charset="-120"/>
+              </a:rPr>
+              <a:t>no loose wires, exhibition-solid</a:t>
+            </a:r>
+            <a:endParaRPr lang="en-US" sz="1200" dirty="0"/>
+          </a:p>
+        </p:txBody>
+      </p:sp>
+      <p:sp>
+        <p:nvSpPr>
+          <p:cNvPr id="8" name="Shape 5"/>
+          <p:cNvSpPr/>
+          <p:nvPr/>
+        </p:nvSpPr>
+        <p:spPr>
+          <a:xfrm>
+            <a:off x="960120" y="3383280"/>
+            <a:ext cx="4480560" cy="713232"/>
+          </a:xfrm>
+          <a:prstGeom prst="roundRect">
+            <a:avLst>
+              <a:gd name="adj" fmla="val 15385"/>
+            </a:avLst>
+          </a:prstGeom>
+          <a:solidFill>
+            <a:srgbClr val="182A23"/>
+          </a:solidFill>
+          <a:ln/>
+        </p:spPr>
+      </p:sp>
+      <p:sp>
+        <p:nvSpPr>
+          <p:cNvPr id="9" name="Text 6"/>
+          <p:cNvSpPr/>
+          <p:nvPr/>
+        </p:nvSpPr>
+        <p:spPr>
+          <a:xfrm>
+            <a:off x="1188720" y="3456432"/>
+            <a:ext cx="4023360" cy="310896"/>
+          </a:xfrm>
+          <a:prstGeom prst="rect">
+            <a:avLst/>
+          </a:prstGeom>
+          <a:noFill/>
+          <a:ln/>
+        </p:spPr>
+        <p:txBody>
+          <a:bodyPr wrap="square" lIns="0" tIns="0" rIns="0" bIns="0" rtlCol="0" anchor="ctr"/>
+          <a:lstStyle/>
+          <a:p>
+            <a:pPr indent="0" marL="0">
+              <a:buNone/>
+            </a:pPr>
+            <a:r>
+              <a:rPr lang="en-US" sz="1400" b="1" dirty="0">
+                <a:solidFill>
+                  <a:srgbClr val="7BE0C9"/>
+                </a:solidFill>
+                <a:latin typeface="Arial" pitchFamily="34" charset="0"/>
+                <a:ea typeface="Arial" pitchFamily="34" charset="-122"/>
+                <a:cs typeface="Arial" pitchFamily="34" charset="-120"/>
+              </a:rPr>
+              <a:t>VL53L0X</a:t>
+            </a:r>
+            <a:endParaRPr lang="en-US" sz="1400" dirty="0"/>
+          </a:p>
+        </p:txBody>
+      </p:sp>
+      <p:sp>
+        <p:nvSpPr>
+          <p:cNvPr id="10" name="Text 7"/>
+          <p:cNvSpPr/>
+          <p:nvPr/>
+        </p:nvSpPr>
+        <p:spPr>
+          <a:xfrm>
+            <a:off x="1188720" y="3749040"/>
+            <a:ext cx="4023360" cy="292608"/>
+          </a:xfrm>
+          <a:prstGeom prst="rect">
+            <a:avLst/>
+          </a:prstGeom>
+          <a:noFill/>
+          <a:ln/>
+        </p:spPr>
+        <p:txBody>
+          <a:bodyPr wrap="square" lIns="0" tIns="0" rIns="0" bIns="0" rtlCol="0" anchor="ctr"/>
+          <a:lstStyle/>
+          <a:p>
+            <a:pPr indent="0" marL="0">
+              <a:buNone/>
+            </a:pPr>
+            <a:r>
+              <a:rPr lang="en-US" sz="1150" dirty="0">
+                <a:solidFill>
+                  <a:srgbClr val="FFFFFF"/>
+                </a:solidFill>
+                <a:latin typeface="Arial" pitchFamily="34" charset="0"/>
+                <a:ea typeface="Arial" pitchFamily="34" charset="-122"/>
+                <a:cs typeface="Arial" pitchFamily="34" charset="-120"/>
+              </a:rPr>
+              <a:t>laser distance — is a reader there?</a:t>
+            </a:r>
+            <a:endParaRPr lang="en-US" sz="1150" dirty="0"/>
+          </a:p>
+        </p:txBody>
+      </p:sp>
+      <p:sp>
+        <p:nvSpPr>
+          <p:cNvPr id="11" name="Shape 8"/>
+          <p:cNvSpPr/>
+          <p:nvPr/>
+        </p:nvSpPr>
+        <p:spPr>
+          <a:xfrm>
+            <a:off x="960120" y="4233672"/>
+            <a:ext cx="4480560" cy="713232"/>
+          </a:xfrm>
+          <a:prstGeom prst="roundRect">
+            <a:avLst>
+              <a:gd name="adj" fmla="val 15385"/>
+            </a:avLst>
+          </a:prstGeom>
+          <a:solidFill>
+            <a:srgbClr val="182A23"/>
+          </a:solidFill>
+          <a:ln/>
+        </p:spPr>
+      </p:sp>
+      <p:sp>
+        <p:nvSpPr>
+          <p:cNvPr id="12" name="Text 9"/>
+          <p:cNvSpPr/>
+          <p:nvPr/>
+        </p:nvSpPr>
+        <p:spPr>
+          <a:xfrm>
+            <a:off x="1188720" y="4306824"/>
+            <a:ext cx="4023360" cy="310896"/>
+          </a:xfrm>
+          <a:prstGeom prst="rect">
+            <a:avLst/>
+          </a:prstGeom>
+          <a:noFill/>
+          <a:ln/>
+        </p:spPr>
+        <p:txBody>
+          <a:bodyPr wrap="square" lIns="0" tIns="0" rIns="0" bIns="0" rtlCol="0" anchor="ctr"/>
+          <a:lstStyle/>
+          <a:p>
+            <a:pPr indent="0" marL="0">
+              <a:buNone/>
+            </a:pPr>
+            <a:r>
+              <a:rPr lang="en-US" sz="1400" b="1" dirty="0">
+                <a:solidFill>
+                  <a:srgbClr val="7BE0C9"/>
+                </a:solidFill>
+                <a:latin typeface="Arial" pitchFamily="34" charset="0"/>
+                <a:ea typeface="Arial" pitchFamily="34" charset="-122"/>
+                <a:cs typeface="Arial" pitchFamily="34" charset="-120"/>
+              </a:rPr>
+              <a:t>BME280</a:t>
+            </a:r>
+            <a:endParaRPr lang="en-US" sz="1400" dirty="0"/>
+          </a:p>
+        </p:txBody>
+      </p:sp>
+      <p:sp>
+        <p:nvSpPr>
+          <p:cNvPr id="13" name="Text 10"/>
+          <p:cNvSpPr/>
+          <p:nvPr/>
+        </p:nvSpPr>
+        <p:spPr>
+          <a:xfrm>
+            <a:off x="1188720" y="4599432"/>
+            <a:ext cx="4023360" cy="292608"/>
+          </a:xfrm>
+          <a:prstGeom prst="rect">
+            <a:avLst/>
+          </a:prstGeom>
+          <a:noFill/>
+          <a:ln/>
+        </p:spPr>
+        <p:txBody>
+          <a:bodyPr wrap="square" lIns="0" tIns="0" rIns="0" bIns="0" rtlCol="0" anchor="ctr"/>
+          <a:lstStyle/>
+          <a:p>
+            <a:pPr indent="0" marL="0">
+              <a:buNone/>
+            </a:pPr>
+            <a:r>
+              <a:rPr lang="en-US" sz="1150" dirty="0">
+                <a:solidFill>
+                  <a:srgbClr val="FFFFFF"/>
+                </a:solidFill>
+                <a:latin typeface="Arial" pitchFamily="34" charset="0"/>
+                <a:ea typeface="Arial" pitchFamily="34" charset="-122"/>
+                <a:cs typeface="Arial" pitchFamily="34" charset="-120"/>
+              </a:rPr>
+              <a:t>temperature &amp; humidity of the room</a:t>
+            </a:r>
+            <a:endParaRPr lang="en-US" sz="1150" dirty="0"/>
+          </a:p>
+        </p:txBody>
+      </p:sp>
+      <p:sp>
+        <p:nvSpPr>
+          <p:cNvPr id="14" name="Shape 11"/>
+          <p:cNvSpPr/>
+          <p:nvPr/>
+        </p:nvSpPr>
+        <p:spPr>
+          <a:xfrm>
+            <a:off x="960120" y="5084064"/>
+            <a:ext cx="4480560" cy="713232"/>
+          </a:xfrm>
+          <a:prstGeom prst="roundRect">
+            <a:avLst>
+              <a:gd name="adj" fmla="val 15385"/>
+            </a:avLst>
+          </a:prstGeom>
+          <a:solidFill>
+            <a:srgbClr val="182A23"/>
+          </a:solidFill>
+          <a:ln/>
+        </p:spPr>
+      </p:sp>
+      <p:sp>
+        <p:nvSpPr>
+          <p:cNvPr id="15" name="Text 12"/>
+          <p:cNvSpPr/>
+          <p:nvPr/>
+        </p:nvSpPr>
+        <p:spPr>
+          <a:xfrm>
+            <a:off x="1188720" y="5157216"/>
+            <a:ext cx="4023360" cy="310896"/>
+          </a:xfrm>
+          <a:prstGeom prst="rect">
+            <a:avLst/>
+          </a:prstGeom>
+          <a:noFill/>
+          <a:ln/>
+        </p:spPr>
+        <p:txBody>
+          <a:bodyPr wrap="square" lIns="0" tIns="0" rIns="0" bIns="0" rtlCol="0" anchor="ctr"/>
+          <a:lstStyle/>
+          <a:p>
+            <a:pPr indent="0" marL="0">
+              <a:buNone/>
+            </a:pPr>
+            <a:r>
+              <a:rPr lang="en-US" sz="1400" b="1" dirty="0">
+                <a:solidFill>
+                  <a:srgbClr val="7BE0C9"/>
+                </a:solidFill>
+                <a:latin typeface="Arial" pitchFamily="34" charset="0"/>
+                <a:ea typeface="Arial" pitchFamily="34" charset="-122"/>
+                <a:cs typeface="Arial" pitchFamily="34" charset="-120"/>
+              </a:rPr>
+              <a:t>PN532 NFC</a:t>
+            </a:r>
+            <a:endParaRPr lang="en-US" sz="1400" dirty="0"/>
+          </a:p>
+        </p:txBody>
+      </p:sp>
+      <p:sp>
+        <p:nvSpPr>
+          <p:cNvPr id="16" name="Text 13"/>
+          <p:cNvSpPr/>
+          <p:nvPr/>
+        </p:nvSpPr>
+        <p:spPr>
+          <a:xfrm>
+            <a:off x="1188720" y="5449824"/>
+            <a:ext cx="4023360" cy="292608"/>
+          </a:xfrm>
+          <a:prstGeom prst="rect">
+            <a:avLst/>
+          </a:prstGeom>
+          <a:noFill/>
+          <a:ln/>
+        </p:spPr>
+        <p:txBody>
+          <a:bodyPr wrap="square" lIns="0" tIns="0" rIns="0" bIns="0" rtlCol="0" anchor="ctr"/>
+          <a:lstStyle/>
+          <a:p>
+            <a:pPr indent="0" marL="0">
+              <a:buNone/>
+            </a:pPr>
+            <a:r>
+              <a:rPr lang="en-US" sz="1150" dirty="0">
+                <a:solidFill>
+                  <a:srgbClr val="FFFFFF"/>
+                </a:solidFill>
+                <a:latin typeface="Arial" pitchFamily="34" charset="0"/>
+                <a:ea typeface="Arial" pitchFamily="34" charset="-122"/>
+                <a:cs typeface="Arial" pitchFamily="34" charset="-120"/>
+              </a:rPr>
+              <a:t>reads the tag inside each book</a:t>
+            </a:r>
+            <a:endParaRPr lang="en-US" sz="1150" dirty="0"/>
+          </a:p>
+        </p:txBody>
+      </p:sp>
+      <p:sp>
+        <p:nvSpPr>
+          <p:cNvPr id="17" name="Shape 14"/>
+          <p:cNvSpPr/>
+          <p:nvPr/>
+        </p:nvSpPr>
+        <p:spPr>
+          <a:xfrm>
+            <a:off x="6263640" y="2286000"/>
+            <a:ext cx="2286000" cy="1188720"/>
+          </a:xfrm>
+          <a:prstGeom prst="roundRect">
+            <a:avLst>
+              <a:gd name="adj" fmla="val 11538"/>
+            </a:avLst>
+          </a:prstGeom>
+          <a:solidFill>
+            <a:srgbClr val="13201B"/>
+          </a:solidFill>
+          <a:ln w="12700">
+            <a:solidFill>
+              <a:srgbClr val="F5B169"/>
+            </a:solidFill>
+            <a:prstDash val="solid"/>
+          </a:ln>
+        </p:spPr>
+      </p:sp>
+      <p:sp>
+        <p:nvSpPr>
+          <p:cNvPr id="18" name="Text 15"/>
+          <p:cNvSpPr/>
+          <p:nvPr/>
+        </p:nvSpPr>
+        <p:spPr>
+          <a:xfrm>
+            <a:off x="6263640" y="2423160"/>
+            <a:ext cx="2286000" cy="457200"/>
+          </a:xfrm>
+          <a:prstGeom prst="rect">
+            <a:avLst/>
+          </a:prstGeom>
+          <a:noFill/>
+          <a:ln/>
+        </p:spPr>
+        <p:txBody>
+          <a:bodyPr wrap="square" lIns="0" tIns="0" rIns="0" bIns="0" rtlCol="0" anchor="ctr"/>
+          <a:lstStyle/>
+          <a:p>
+            <a:pPr algn="ctr" indent="0" marL="0">
+              <a:buNone/>
+            </a:pPr>
+            <a:r>
+              <a:rPr lang="en-US" sz="1500" b="1" dirty="0">
+                <a:solidFill>
+                  <a:srgbClr val="FFFFFF"/>
+                </a:solidFill>
+                <a:latin typeface="Arial" pitchFamily="34" charset="0"/>
+                <a:ea typeface="Arial" pitchFamily="34" charset="-122"/>
+                <a:cs typeface="Arial" pitchFamily="34" charset="-120"/>
+              </a:rPr>
+              <a:t>sensor box</a:t>
+            </a:r>
+            <a:endParaRPr lang="en-US" sz="1500" dirty="0"/>
+          </a:p>
+        </p:txBody>
+      </p:sp>
+      <p:sp>
+        <p:nvSpPr>
+          <p:cNvPr id="19" name="Text 16"/>
+          <p:cNvSpPr/>
+          <p:nvPr/>
+        </p:nvSpPr>
+        <p:spPr>
+          <a:xfrm>
+            <a:off x="6263640" y="2880360"/>
+            <a:ext cx="2286000" cy="365760"/>
+          </a:xfrm>
+          <a:prstGeom prst="rect">
+            <a:avLst/>
+          </a:prstGeom>
+          <a:noFill/>
+          <a:ln/>
+        </p:spPr>
+        <p:txBody>
+          <a:bodyPr wrap="square" lIns="0" tIns="0" rIns="0" bIns="0" rtlCol="0" anchor="ctr"/>
+          <a:lstStyle/>
+          <a:p>
+            <a:pPr algn="ctr" indent="0" marL="0">
+              <a:buNone/>
+            </a:pPr>
+            <a:r>
+              <a:rPr lang="en-US" sz="1100" dirty="0">
+                <a:solidFill>
+                  <a:srgbClr val="93A8A1"/>
+                </a:solidFill>
+                <a:latin typeface="Arial" pitchFamily="34" charset="0"/>
+                <a:ea typeface="Arial" pitchFamily="34" charset="-122"/>
+                <a:cs typeface="Arial" pitchFamily="34" charset="-120"/>
+              </a:rPr>
+              <a:t>reads the room</a:t>
+            </a:r>
+            <a:endParaRPr lang="en-US" sz="1100" dirty="0"/>
+          </a:p>
+        </p:txBody>
+      </p:sp>
+      <p:pic>
+        <p:nvPicPr>
+          <p:cNvPr id="20" name="Image 1" descr="preencoded.png">    </p:cNvPr>
+          <p:cNvPicPr>
+            <a:picLocks noChangeAspect="1"/>
+          </p:cNvPicPr>
+          <p:nvPr/>
+        </p:nvPicPr>
+        <p:blipFill>
+          <a:blip r:embed="rId2"/>
+          <a:stretch>
+            <a:fillRect/>
+          </a:stretch>
+        </p:blipFill>
+        <p:spPr>
+          <a:xfrm>
+            <a:off x="8823960" y="2514600"/>
+            <a:ext cx="548640" cy="548640"/>
+          </a:xfrm>
+          <a:prstGeom prst="rect">
+            <a:avLst/>
+          </a:prstGeom>
+        </p:spPr>
+      </p:pic>
+      <p:sp>
+        <p:nvSpPr>
+          <p:cNvPr id="21" name="Text 17"/>
+          <p:cNvSpPr/>
+          <p:nvPr/>
+        </p:nvSpPr>
+        <p:spPr>
+          <a:xfrm>
+            <a:off x="8458200" y="3154680"/>
+            <a:ext cx="1371600" cy="502920"/>
+          </a:xfrm>
+          <a:prstGeom prst="rect">
+            <a:avLst/>
+          </a:prstGeom>
+          <a:noFill/>
+          <a:ln/>
+        </p:spPr>
+        <p:txBody>
+          <a:bodyPr wrap="square" lIns="0" tIns="0" rIns="0" bIns="0" rtlCol="0" anchor="ctr"/>
+          <a:lstStyle/>
+          <a:p>
+            <a:pPr algn="ctr" indent="0" marL="0">
+              <a:lnSpc>
+                <a:spcPts val="1300"/>
+              </a:lnSpc>
+              <a:buNone/>
+            </a:pPr>
+            <a:r>
+              <a:rPr lang="en-US" sz="1050" dirty="0">
+                <a:solidFill>
+                  <a:srgbClr val="7BE0C9"/>
+                </a:solidFill>
+                <a:latin typeface="Arial" pitchFamily="34" charset="0"/>
+                <a:ea typeface="Arial" pitchFamily="34" charset="-122"/>
+                <a:cs typeface="Arial" pitchFamily="34" charset="-120"/>
+              </a:rPr>
+              <a:t>its own Wi-Fi hotspot</a:t>
+            </a:r>
+            <a:endParaRPr lang="en-US" sz="1050" dirty="0"/>
+          </a:p>
+        </p:txBody>
+      </p:sp>
+      <p:sp>
+        <p:nvSpPr>
+          <p:cNvPr id="22" name="Shape 18"/>
+          <p:cNvSpPr/>
+          <p:nvPr/>
+        </p:nvSpPr>
+        <p:spPr>
+          <a:xfrm>
+            <a:off x="9646920" y="2286000"/>
+            <a:ext cx="1920240" cy="1188720"/>
+          </a:xfrm>
+          <a:prstGeom prst="roundRect">
+            <a:avLst>
+              <a:gd name="adj" fmla="val 11538"/>
+            </a:avLst>
+          </a:prstGeom>
+          <a:solidFill>
+            <a:srgbClr val="13201B"/>
+          </a:solidFill>
+          <a:ln w="12700">
+            <a:solidFill>
+              <a:srgbClr val="7BE0C9"/>
+            </a:solidFill>
+            <a:prstDash val="solid"/>
+          </a:ln>
+        </p:spPr>
+      </p:sp>
+      <p:sp>
+        <p:nvSpPr>
+          <p:cNvPr id="23" name="Text 19"/>
+          <p:cNvSpPr/>
+          <p:nvPr/>
+        </p:nvSpPr>
+        <p:spPr>
+          <a:xfrm>
+            <a:off x="9646920" y="2423160"/>
+            <a:ext cx="1920240" cy="457200"/>
+          </a:xfrm>
+          <a:prstGeom prst="rect">
+            <a:avLst/>
+          </a:prstGeom>
+          <a:noFill/>
+          <a:ln/>
+        </p:spPr>
+        <p:txBody>
+          <a:bodyPr wrap="square" lIns="0" tIns="0" rIns="0" bIns="0" rtlCol="0" anchor="ctr"/>
+          <a:lstStyle/>
+          <a:p>
+            <a:pPr algn="ctr" indent="0" marL="0">
+              <a:buNone/>
+            </a:pPr>
+            <a:r>
+              <a:rPr lang="en-US" sz="1500" b="1" dirty="0">
+                <a:solidFill>
+                  <a:srgbClr val="FFFFFF"/>
+                </a:solidFill>
+                <a:latin typeface="Arial" pitchFamily="34" charset="0"/>
+                <a:ea typeface="Arial" pitchFamily="34" charset="-122"/>
+                <a:cs typeface="Arial" pitchFamily="34" charset="-120"/>
+              </a:rPr>
+              <a:t>iPad</a:t>
+            </a:r>
+            <a:endParaRPr lang="en-US" sz="1500" dirty="0"/>
+          </a:p>
+        </p:txBody>
+      </p:sp>
+      <p:sp>
+        <p:nvSpPr>
+          <p:cNvPr id="24" name="Text 20"/>
+          <p:cNvSpPr/>
+          <p:nvPr/>
+        </p:nvSpPr>
+        <p:spPr>
+          <a:xfrm>
+            <a:off x="9646920" y="2880360"/>
+            <a:ext cx="1920240" cy="365760"/>
+          </a:xfrm>
+          <a:prstGeom prst="rect">
+            <a:avLst/>
+          </a:prstGeom>
+          <a:noFill/>
+          <a:ln/>
+        </p:spPr>
+        <p:txBody>
+          <a:bodyPr wrap="square" lIns="0" tIns="0" rIns="0" bIns="0" rtlCol="0" anchor="ctr"/>
+          <a:lstStyle/>
+          <a:p>
+            <a:pPr algn="ctr" indent="0" marL="0">
+              <a:buNone/>
+            </a:pPr>
+            <a:r>
+              <a:rPr lang="en-US" sz="1100" dirty="0">
+                <a:solidFill>
+                  <a:srgbClr val="93A8A1"/>
+                </a:solidFill>
+                <a:latin typeface="Arial" pitchFamily="34" charset="0"/>
+                <a:ea typeface="Arial" pitchFamily="34" charset="-122"/>
+                <a:cs typeface="Arial" pitchFamily="34" charset="-120"/>
+              </a:rPr>
+              <a:t>asks every 1 s</a:t>
+            </a:r>
+            <a:endParaRPr lang="en-US" sz="1100" dirty="0"/>
+          </a:p>
+        </p:txBody>
+      </p:sp>
+      <p:sp>
+        <p:nvSpPr>
+          <p:cNvPr id="25" name="Text 21"/>
+          <p:cNvSpPr/>
+          <p:nvPr/>
+        </p:nvSpPr>
+        <p:spPr>
+          <a:xfrm>
+            <a:off x="6263640" y="3886200"/>
+            <a:ext cx="5303520" cy="548640"/>
+          </a:xfrm>
+          <a:prstGeom prst="rect">
+            <a:avLst/>
+          </a:prstGeom>
+          <a:noFill/>
+          <a:ln/>
+        </p:spPr>
+        <p:txBody>
+          <a:bodyPr wrap="square" lIns="0" tIns="0" rIns="0" bIns="0" rtlCol="0" anchor="ctr"/>
+          <a:lstStyle/>
+          <a:p>
+            <a:pPr indent="0" marL="0">
+              <a:lnSpc>
+                <a:spcPts val="1700"/>
+              </a:lnSpc>
+              <a:buNone/>
+            </a:pPr>
+            <a:r>
+              <a:rPr lang="en-US" sz="1250" dirty="0">
+                <a:solidFill>
+                  <a:srgbClr val="FFFFFF"/>
+                </a:solidFill>
+                <a:latin typeface="Arial" pitchFamily="34" charset="0"/>
+                <a:ea typeface="Arial" pitchFamily="34" charset="-122"/>
+                <a:cs typeface="Arial" pitchFamily="34" charset="-120"/>
+              </a:rPr>
+              <a:t>sensor data travels as tiny JSON messages over the local hotspot — one request per second</a:t>
+            </a:r>
+            <a:endParaRPr lang="en-US" sz="1250" dirty="0"/>
+          </a:p>
+        </p:txBody>
+      </p:sp>
+      <p:sp>
+        <p:nvSpPr>
+          <p:cNvPr id="26" name="Shape 22"/>
+          <p:cNvSpPr/>
+          <p:nvPr/>
+        </p:nvSpPr>
+        <p:spPr>
+          <a:xfrm>
+            <a:off x="6263640" y="4709160"/>
+            <a:ext cx="5303520" cy="914400"/>
+          </a:xfrm>
+          <a:prstGeom prst="roundRect">
+            <a:avLst>
+              <a:gd name="adj" fmla="val 15000"/>
+            </a:avLst>
+          </a:prstGeom>
+          <a:solidFill>
+            <a:srgbClr val="182A23"/>
+          </a:solidFill>
+          <a:ln/>
+        </p:spPr>
+      </p:sp>
+      <p:sp>
+        <p:nvSpPr>
+          <p:cNvPr id="27" name="Text 23"/>
+          <p:cNvSpPr/>
+          <p:nvPr/>
+        </p:nvSpPr>
+        <p:spPr>
+          <a:xfrm>
+            <a:off x="6492240" y="4846320"/>
+            <a:ext cx="4846320" cy="640080"/>
+          </a:xfrm>
+          <a:prstGeom prst="rect">
+            <a:avLst/>
+          </a:prstGeom>
+          <a:noFill/>
+          <a:ln/>
+        </p:spPr>
+        <p:txBody>
+          <a:bodyPr wrap="square" lIns="0" tIns="0" rIns="0" bIns="0" rtlCol="0" anchor="ctr"/>
+          <a:lstStyle/>
+          <a:p>
+            <a:pPr indent="0" marL="0">
+              <a:lnSpc>
+                <a:spcPts val="1700"/>
+              </a:lnSpc>
+              <a:buNone/>
+            </a:pPr>
+            <a:r>
+              <a:rPr lang="en-US" sz="1300" b="1" dirty="0">
+                <a:solidFill>
+                  <a:srgbClr val="7BE0C9"/>
+                </a:solidFill>
+                <a:latin typeface="Arial" pitchFamily="34" charset="0"/>
+                <a:ea typeface="Arial" pitchFamily="34" charset="-122"/>
+                <a:cs typeface="Arial" pitchFamily="34" charset="-120"/>
+              </a:rPr>
+              <a:t>no internet · no cloud · no server —</a:t>
+            </a:r>
+            <a:endParaRPr lang="en-US" sz="1300" dirty="0"/>
+          </a:p>
+          <a:p>
+            <a:pPr indent="0" marL="0">
+              <a:lnSpc>
+                <a:spcPts val="1700"/>
+              </a:lnSpc>
+              <a:buNone/>
+            </a:pPr>
+            <a:r>
+              <a:rPr lang="en-US" sz="1300" b="1" dirty="0">
+                <a:solidFill>
+                  <a:srgbClr val="7BE0C9"/>
+                </a:solidFill>
+                <a:latin typeface="Arial" pitchFamily="34" charset="0"/>
+                <a:ea typeface="Arial" pitchFamily="34" charset="-122"/>
+                <a:cs typeface="Arial" pitchFamily="34" charset="-120"/>
+              </a:rPr>
+              <a:t>everything stays on this desk</a:t>
+            </a:r>
+            <a:endParaRPr lang="en-US" sz="1300" dirty="0"/>
+          </a:p>
+        </p:txBody>
+      </p:sp>
+    </p:spTree>
+  </p:cSld>
+  <p:clrMapOvr>
+    <a:masterClrMapping/>
+  </p:clrMapOvr>
+</p:sld>
+</file>
+
+<file path=ppt/slides/slide7.xml><?xml version="1.0" encoding="utf-8"?>
+<p:sld xmlns:a="http://schemas.openxmlformats.org/drawingml/2006/main" xmlns:r="http://schemas.openxmlformats.org/officeDocument/2006/relationships" xmlns:p="http://schemas.openxmlformats.org/presentationml/2006/main">
+  <p:cSld name="Slide 7">
+    <p:bg>
+      <p:bgPr>
+        <a:solidFill>
+          <a:srgbClr val="0A0F0D"/>
+        </a:solidFill>
+      </p:bgPr>
+    </p:bg>
+    <p:spTree>
+      <p:nvGrpSpPr>
+        <p:cNvPr id="1" name=""/>
+        <p:cNvGrpSpPr/>
+        <p:nvPr/>
+      </p:nvGrpSpPr>
+      <p:grpSpPr>
+        <a:xfrm>
+          <a:off x="0" y="0"/>
+          <a:ext cx="0" cy="0"/>
+          <a:chOff x="0" y="0"/>
+          <a:chExt cx="0" cy="0"/>
+        </a:xfrm>
+      </p:grpSpPr>
+      <p:sp>
+        <p:nvSpPr>
+          <p:cNvPr id="2" name="Shape 0"/>
+          <p:cNvSpPr/>
+          <p:nvPr/>
+        </p:nvSpPr>
+        <p:spPr>
+          <a:xfrm>
+            <a:off x="640080" y="566928"/>
+            <a:ext cx="777240" cy="777240"/>
+          </a:xfrm>
+          <a:prstGeom prst="ellipse">
+            <a:avLst/>
+          </a:prstGeom>
+          <a:solidFill>
+            <a:srgbClr val="182A23"/>
+          </a:solidFill>
+          <a:ln w="9525">
+            <a:solidFill>
+              <a:srgbClr val="7BE0C9"/>
+            </a:solidFill>
+            <a:prstDash val="solid"/>
+          </a:ln>
+        </p:spPr>
+      </p:sp>
+      <p:pic>
+        <p:nvPicPr>
+          <p:cNvPr id="3" name="Image 0" descr="preencoded.png">    </p:cNvPr>
+          <p:cNvPicPr>
+            <a:picLocks noChangeAspect="1"/>
+          </p:cNvPicPr>
+          <p:nvPr/>
+        </p:nvPicPr>
+        <p:blipFill>
+          <a:blip r:embed="rId1"/>
+          <a:stretch>
+            <a:fillRect/>
+          </a:stretch>
+        </p:blipFill>
+        <p:spPr>
+          <a:xfrm>
+            <a:off x="826618" y="753466"/>
+            <a:ext cx="404165" cy="404165"/>
+          </a:xfrm>
+          <a:prstGeom prst="rect">
+            <a:avLst/>
+          </a:prstGeom>
+        </p:spPr>
+      </p:pic>
+      <p:sp>
+        <p:nvSpPr>
+          <p:cNvPr id="4" name="Text 1"/>
+          <p:cNvSpPr/>
+          <p:nvPr/>
+        </p:nvSpPr>
+        <p:spPr>
+          <a:xfrm>
+            <a:off x="1600200" y="566928"/>
             <a:ext cx="7315200" cy="777240"/>
           </a:xfrm>
           <a:prstGeom prst="rect">

</xml_diff>